<commit_message>
Fill MCC dimensions/weight from Schneider datasheets and Reference in Table1
Co-Authored-By: Claude Opus 5.5 <noreply@anthropic.com>
Claude-Session: https://claude.ai/code/session_01GjFrCobQqqs1TtLcuKd8BA
</commit_message>
<xml_diff>
--- a/최종_제출본/PLC_사양서_261006_수정.pptx
+++ b/최종_제출본/PLC_사양서_261006_수정.pptx
@@ -9484,7 +9484,7 @@
                             <a:srgbClr val="FF0000"/>
                           </a:solidFill>
                         </a:rPr>
-                        <a:t>CPU 190×95×90</a:t>
+                        <a:t>190 × 95 × 90</a:t>
                       </a:r>
                     </a:p>
                     <a:p>
@@ -9511,54 +9511,9 @@
                             <a:srgbClr val="FF0000"/>
                           </a:solidFill>
                         </a:rPr>
-                        <a:t>[모듈 치수 확인]</a:t>
-                      </a:r>
-                    </a:p>
-                  </a:txBody>
-                  <a:tcPr anchor="ctr"/>
-                </a:tc>
-                <a:extLst>
-                  <a:ext uri="{0D108BD9-81ED-4DB2-BD59-A6C34878D82A}">
-                    <a16:rowId xmlns:a16="http://schemas.microsoft.com/office/drawing/2014/main" val="2224850264"/>
-                  </a:ext>
-                </a:extLst>
-              </a:tr>
-              <a:tr h="405350">
-                <a:tc>
-                  <a:txBody>
-                    <a:bodyPr/>
-                    <a:lstStyle/>
-                    <a:p>
-                      <a:pPr algn="ctr" latinLnBrk="1"/>
-                      <a:r>
-                        <a:rPr lang="ko-KR" altLang="en-US" sz="1100" dirty="0"/>
-                        <a:t>무게</a:t>
-                      </a:r>
-                      <a:endParaRPr lang="en-US" altLang="ko-KR" sz="1100" dirty="0"/>
-                    </a:p>
-                    <a:p>
-                      <a:pPr algn="ctr" latinLnBrk="1"/>
-                      <a:r>
-                        <a:rPr lang="en-US" altLang="ko-KR" sz="1100" dirty="0"/>
-                        <a:t>(Card</a:t>
-                      </a:r>
-                      <a:r>
-                        <a:rPr lang="ko-KR" altLang="en-US" sz="1100" dirty="0"/>
-                        <a:t>포함</a:t>
-                      </a:r>
-                      <a:r>
-                        <a:rPr lang="en-US" altLang="ko-KR" sz="1100" dirty="0"/>
-                        <a:t>)</a:t>
-                      </a:r>
-                      <a:endParaRPr lang="ko-KR" altLang="en-US" sz="1100" dirty="0"/>
-                    </a:p>
-                  </a:txBody>
-                  <a:tcPr anchor="ctr"/>
-                </a:tc>
-                <a:tc>
-                  <a:txBody>
-                    <a:bodyPr/>
-                    <a:lstStyle/>
+                        <a:t>27.4 × 84.6 × 90 ×8</a:t>
+                      </a:r>
+                    </a:p>
                     <a:p>
                       <a:pPr marL="0" marR="0" lvl="0" indent="0" algn="ctr" defTabSz="914400" rtl="0" eaLnBrk="1" fontAlgn="auto" latinLnBrk="1" hangingPunct="1">
                         <a:lnSpc>
@@ -9578,18 +9533,14 @@
                         <a:defRPr/>
                       </a:pPr>
                       <a:r>
-                        <a:rPr lang="en-US" altLang="ko-KR" sz="1100" dirty="0"/>
-                        <a:t>0.42 kg</a:t>
-                      </a:r>
-                      <a:endParaRPr lang="ko-KR" altLang="en-US" sz="1100" dirty="0"/>
-                    </a:p>
-                  </a:txBody>
-                  <a:tcPr anchor="ctr"/>
-                </a:tc>
-                <a:tc>
-                  <a:txBody>
-                    <a:bodyPr/>
-                    <a:lstStyle/>
+                        <a:rPr lang="pl-PL" altLang="ko-KR" sz="700" dirty="0">
+                          <a:solidFill>
+                            <a:srgbClr val="FF0000"/>
+                          </a:solidFill>
+                        </a:rPr>
+                        <a:t>23.6 × 70 × 90</a:t>
+                      </a:r>
+                    </a:p>
                     <a:p>
                       <a:pPr marL="0" marR="0" lvl="0" indent="0" algn="ctr" defTabSz="914400" rtl="0" eaLnBrk="1" fontAlgn="auto" latinLnBrk="1" hangingPunct="1">
                         <a:lnSpc>
@@ -9609,8 +9560,49 @@
                         <a:defRPr/>
                       </a:pPr>
                       <a:r>
+                        <a:rPr lang="pl-PL" altLang="ko-KR" sz="700" dirty="0">
+                          <a:solidFill>
+                            <a:srgbClr val="FF0000"/>
+                          </a:solidFill>
+                        </a:rPr>
+                        <a:t>23.65 × 73.3 × 90 ×2</a:t>
+                      </a:r>
+                    </a:p>
+                  </a:txBody>
+                  <a:tcPr anchor="ctr"/>
+                </a:tc>
+                <a:extLst>
+                  <a:ext uri="{0D108BD9-81ED-4DB2-BD59-A6C34878D82A}">
+                    <a16:rowId xmlns:a16="http://schemas.microsoft.com/office/drawing/2014/main" val="2224850264"/>
+                  </a:ext>
+                </a:extLst>
+              </a:tr>
+              <a:tr h="405350">
+                <a:tc>
+                  <a:txBody>
+                    <a:bodyPr/>
+                    <a:lstStyle/>
+                    <a:p>
+                      <a:pPr algn="ctr" latinLnBrk="1"/>
+                      <a:r>
+                        <a:rPr lang="ko-KR" altLang="en-US" sz="1100" dirty="0"/>
+                        <a:t>무게</a:t>
+                      </a:r>
+                      <a:endParaRPr lang="en-US" altLang="ko-KR" sz="1100" dirty="0"/>
+                    </a:p>
+                    <a:p>
+                      <a:pPr algn="ctr" latinLnBrk="1"/>
+                      <a:r>
                         <a:rPr lang="en-US" altLang="ko-KR" sz="1100" dirty="0"/>
-                        <a:t>0.42 kg</a:t>
+                        <a:t>(Card</a:t>
+                      </a:r>
+                      <a:r>
+                        <a:rPr lang="ko-KR" altLang="en-US" sz="1100" dirty="0"/>
+                        <a:t>포함</a:t>
+                      </a:r>
+                      <a:r>
+                        <a:rPr lang="en-US" altLang="ko-KR" sz="1100" dirty="0"/>
+                        <a:t>)</a:t>
                       </a:r>
                       <a:endParaRPr lang="ko-KR" altLang="en-US" sz="1100" dirty="0"/>
                     </a:p>
@@ -9641,22 +9633,7 @@
                       </a:pPr>
                       <a:r>
                         <a:rPr lang="en-US" altLang="ko-KR" sz="1100" dirty="0"/>
-                        <a:t>0.53 kg</a:t>
-                      </a:r>
-                      <a:endParaRPr lang="ko-KR" altLang="en-US" sz="1100" dirty="0"/>
-                    </a:p>
-                  </a:txBody>
-                  <a:tcPr anchor="ctr"/>
-                </a:tc>
-                <a:tc>
-                  <a:txBody>
-                    <a:bodyPr/>
-                    <a:lstStyle/>
-                    <a:p>
-                      <a:pPr algn="ctr" latinLnBrk="1"/>
-                      <a:r>
-                        <a:rPr lang="en-US" altLang="ko-KR" sz="1100" dirty="0"/>
-                        <a:t>0.53 kg</a:t>
+                        <a:t>0.42 kg</a:t>
                       </a:r>
                       <a:endParaRPr lang="ko-KR" altLang="en-US" sz="1100" dirty="0"/>
                     </a:p>
@@ -9687,7 +9664,7 @@
                       </a:pPr>
                       <a:r>
                         <a:rPr lang="en-US" altLang="ko-KR" sz="1100" dirty="0"/>
-                        <a:t>0.535 kg</a:t>
+                        <a:t>0.42 kg</a:t>
                       </a:r>
                       <a:endParaRPr lang="ko-KR" altLang="en-US" sz="1100" dirty="0"/>
                     </a:p>
@@ -9718,7 +9695,22 @@
                       </a:pPr>
                       <a:r>
                         <a:rPr lang="en-US" altLang="ko-KR" sz="1100" dirty="0"/>
-                        <a:t>0.535 kg</a:t>
+                        <a:t>0.53 kg</a:t>
+                      </a:r>
+                      <a:endParaRPr lang="ko-KR" altLang="en-US" sz="1100" dirty="0"/>
+                    </a:p>
+                  </a:txBody>
+                  <a:tcPr anchor="ctr"/>
+                </a:tc>
+                <a:tc>
+                  <a:txBody>
+                    <a:bodyPr/>
+                    <a:lstStyle/>
+                    <a:p>
+                      <a:pPr algn="ctr" latinLnBrk="1"/>
+                      <a:r>
+                        <a:rPr lang="en-US" altLang="ko-KR" sz="1100" dirty="0"/>
+                        <a:t>0.53 kg</a:t>
                       </a:r>
                       <a:endParaRPr lang="ko-KR" altLang="en-US" sz="1100" dirty="0"/>
                     </a:p>
@@ -9748,250 +9740,8 @@
                         <a:defRPr/>
                       </a:pPr>
                       <a:r>
-                        <a:rPr lang="en-US" altLang="ko-KR" sz="1100" dirty="0">
-                          <a:solidFill>
-                            <a:srgbClr val="FF0000"/>
-                          </a:solidFill>
-                        </a:rPr>
-                        <a:t>[확인 필요]</a:t>
-                      </a:r>
-                    </a:p>
-                  </a:txBody>
-                  <a:tcPr anchor="ctr"/>
-                </a:tc>
-                <a:extLst>
-                  <a:ext uri="{0D108BD9-81ED-4DB2-BD59-A6C34878D82A}">
-                    <a16:rowId xmlns:a16="http://schemas.microsoft.com/office/drawing/2014/main" val="1215849545"/>
-                  </a:ext>
-                </a:extLst>
-              </a:tr>
-              <a:tr h="405350">
-                <a:tc>
-                  <a:txBody>
-                    <a:bodyPr/>
-                    <a:lstStyle/>
-                    <a:p>
-                      <a:pPr algn="ctr" latinLnBrk="1"/>
-                      <a:r>
-                        <a:rPr lang="ko-KR" altLang="en-US" sz="1100" dirty="0"/>
-                        <a:t>메모리</a:t>
-                      </a:r>
-                    </a:p>
-                  </a:txBody>
-                  <a:tcPr anchor="ctr"/>
-                </a:tc>
-                <a:tc>
-                  <a:txBody>
-                    <a:bodyPr/>
-                    <a:lstStyle/>
-                    <a:p>
-                      <a:pPr algn="ctr" latinLnBrk="1"/>
-                      <a:r>
-                        <a:rPr lang="ko-KR" altLang="ko-KR" sz="1100" dirty="0"/>
-                        <a:t>64 MB RAM</a:t>
-                      </a:r>
-                      <a:endParaRPr lang="en-US" altLang="ko-KR" sz="1100" dirty="0"/>
-                    </a:p>
-                    <a:p>
-                      <a:pPr algn="ctr" latinLnBrk="1"/>
-                      <a:r>
-                        <a:rPr lang="ko-KR" altLang="ko-KR" sz="1100" dirty="0"/>
-                        <a:t>128 MB </a:t>
-                      </a:r>
-                      <a:r>
-                        <a:rPr lang="ko-KR" altLang="ko-KR" sz="1100" dirty="0" err="1"/>
-                        <a:t>Flash</a:t>
-                      </a:r>
-                      <a:endParaRPr lang="en-US" altLang="ko-KR" sz="1100" dirty="0"/>
-                    </a:p>
-                  </a:txBody>
-                  <a:tcPr anchor="ctr"/>
-                </a:tc>
-                <a:tc>
-                  <a:txBody>
-                    <a:bodyPr/>
-                    <a:lstStyle/>
-                    <a:p>
-                      <a:pPr algn="ctr" latinLnBrk="1"/>
-                      <a:r>
-                        <a:rPr lang="ko-KR" altLang="ko-KR" sz="1100" dirty="0"/>
-                        <a:t>64 MB RAM</a:t>
-                      </a:r>
-                      <a:endParaRPr lang="en-US" altLang="ko-KR" sz="1100" dirty="0"/>
-                    </a:p>
-                    <a:p>
-                      <a:pPr algn="ctr" latinLnBrk="1"/>
-                      <a:r>
-                        <a:rPr lang="ko-KR" altLang="ko-KR" sz="1100" dirty="0"/>
-                        <a:t>128 MB </a:t>
-                      </a:r>
-                      <a:r>
-                        <a:rPr lang="ko-KR" altLang="ko-KR" sz="1100" dirty="0" err="1"/>
-                        <a:t>Flash</a:t>
-                      </a:r>
-                      <a:endParaRPr lang="en-US" altLang="ko-KR" sz="1100" dirty="0"/>
-                    </a:p>
-                  </a:txBody>
-                  <a:tcPr anchor="ctr"/>
-                </a:tc>
-                <a:tc>
-                  <a:txBody>
-                    <a:bodyPr/>
-                    <a:lstStyle/>
-                    <a:p>
-                      <a:pPr algn="ctr" latinLnBrk="1"/>
-                      <a:r>
-                        <a:rPr lang="ko-KR" altLang="ko-KR" sz="1100" dirty="0"/>
-                        <a:t>64 MB RAM</a:t>
-                      </a:r>
-                      <a:endParaRPr lang="en-US" altLang="ko-KR" sz="1100" dirty="0"/>
-                    </a:p>
-                    <a:p>
-                      <a:pPr algn="ctr" latinLnBrk="1"/>
-                      <a:r>
-                        <a:rPr lang="ko-KR" altLang="ko-KR" sz="1100" dirty="0"/>
-                        <a:t>128 MB </a:t>
-                      </a:r>
-                      <a:r>
-                        <a:rPr lang="ko-KR" altLang="ko-KR" sz="1100" dirty="0" err="1"/>
-                        <a:t>Flash</a:t>
-                      </a:r>
-                      <a:endParaRPr lang="en-US" altLang="ko-KR" sz="1100" dirty="0"/>
-                    </a:p>
-                  </a:txBody>
-                  <a:tcPr anchor="ctr"/>
-                </a:tc>
-                <a:tc>
-                  <a:txBody>
-                    <a:bodyPr/>
-                    <a:lstStyle/>
-                    <a:p>
-                      <a:pPr algn="ctr" latinLnBrk="1"/>
-                      <a:r>
-                        <a:rPr lang="ko-KR" altLang="ko-KR" sz="1100" dirty="0"/>
-                        <a:t>64 MB RAM</a:t>
-                      </a:r>
-                      <a:endParaRPr lang="en-US" altLang="ko-KR" sz="1100" dirty="0"/>
-                    </a:p>
-                    <a:p>
-                      <a:pPr algn="ctr" latinLnBrk="1"/>
-                      <a:r>
-                        <a:rPr lang="ko-KR" altLang="ko-KR" sz="1100" dirty="0"/>
-                        <a:t>128 MB </a:t>
-                      </a:r>
-                      <a:r>
-                        <a:rPr lang="ko-KR" altLang="ko-KR" sz="1100" dirty="0" err="1"/>
-                        <a:t>Flash</a:t>
-                      </a:r>
-                      <a:endParaRPr lang="en-US" altLang="ko-KR" sz="1100" dirty="0"/>
-                    </a:p>
-                  </a:txBody>
-                  <a:tcPr anchor="ctr"/>
-                </a:tc>
-                <a:tc>
-                  <a:txBody>
-                    <a:bodyPr/>
-                    <a:lstStyle/>
-                    <a:p>
-                      <a:pPr algn="ctr" latinLnBrk="1"/>
-                      <a:r>
-                        <a:rPr lang="ko-KR" altLang="ko-KR" sz="1100" dirty="0"/>
-                        <a:t>64 MB RAM</a:t>
-                      </a:r>
-                      <a:endParaRPr lang="en-US" altLang="ko-KR" sz="1100" dirty="0"/>
-                    </a:p>
-                    <a:p>
-                      <a:pPr algn="ctr" latinLnBrk="1"/>
-                      <a:r>
-                        <a:rPr lang="ko-KR" altLang="ko-KR" sz="1100" dirty="0"/>
-                        <a:t>128 MB </a:t>
-                      </a:r>
-                      <a:r>
-                        <a:rPr lang="ko-KR" altLang="ko-KR" sz="1100" dirty="0" err="1"/>
-                        <a:t>Flash</a:t>
-                      </a:r>
-                      <a:endParaRPr lang="en-US" altLang="ko-KR" sz="1100" dirty="0"/>
-                    </a:p>
-                  </a:txBody>
-                  <a:tcPr anchor="ctr"/>
-                </a:tc>
-                <a:tc>
-                  <a:txBody>
-                    <a:bodyPr/>
-                    <a:lstStyle/>
-                    <a:p>
-                      <a:pPr algn="ctr" latinLnBrk="1"/>
-                      <a:r>
-                        <a:rPr lang="ko-KR" altLang="ko-KR" sz="1100" dirty="0"/>
-                        <a:t>64 MB RAM</a:t>
-                      </a:r>
-                      <a:endParaRPr lang="en-US" altLang="ko-KR" sz="1100" dirty="0"/>
-                    </a:p>
-                    <a:p>
-                      <a:pPr algn="ctr" latinLnBrk="1"/>
-                      <a:r>
-                        <a:rPr lang="ko-KR" altLang="ko-KR" sz="1100" dirty="0"/>
-                        <a:t>128 MB </a:t>
-                      </a:r>
-                      <a:r>
-                        <a:rPr lang="ko-KR" altLang="ko-KR" sz="1100" dirty="0" err="1"/>
-                        <a:t>Flash</a:t>
-                      </a:r>
-                      <a:endParaRPr lang="en-US" altLang="ko-KR" sz="1100" dirty="0"/>
-                    </a:p>
-                  </a:txBody>
-                  <a:tcPr anchor="ctr"/>
-                </a:tc>
-                <a:tc>
-                  <a:txBody>
-                    <a:bodyPr/>
-                    <a:lstStyle/>
-                    <a:p>
-                      <a:pPr algn="ctr" latinLnBrk="1"/>
-                      <a:r>
-                        <a:rPr lang="ko-KR" altLang="ko-KR" sz="1100" dirty="0"/>
-                        <a:t>64 MB RAM</a:t>
-                      </a:r>
-                      <a:endParaRPr lang="en-US" altLang="ko-KR" sz="1100" dirty="0"/>
-                    </a:p>
-                    <a:p>
-                      <a:pPr algn="ctr" latinLnBrk="1"/>
-                      <a:r>
-                        <a:rPr lang="ko-KR" altLang="ko-KR" sz="1100" dirty="0"/>
-                        <a:t>128 MB </a:t>
-                      </a:r>
-                      <a:r>
-                        <a:rPr lang="ko-KR" altLang="ko-KR" sz="1100" dirty="0" err="1"/>
-                        <a:t>Flash</a:t>
-                      </a:r>
-                      <a:endParaRPr lang="en-US" altLang="ko-KR" sz="1100" dirty="0"/>
-                    </a:p>
-                  </a:txBody>
-                  <a:tcPr anchor="ctr"/>
-                </a:tc>
-                <a:extLst>
-                  <a:ext uri="{0D108BD9-81ED-4DB2-BD59-A6C34878D82A}">
-                    <a16:rowId xmlns:a16="http://schemas.microsoft.com/office/drawing/2014/main" val="2379048894"/>
-                  </a:ext>
-                </a:extLst>
-              </a:tr>
-              <a:tr h="405350">
-                <a:tc>
-                  <a:txBody>
-                    <a:bodyPr/>
-                    <a:lstStyle/>
-                    <a:p>
-                      <a:pPr algn="ctr" latinLnBrk="1"/>
-                      <a:r>
                         <a:rPr lang="en-US" altLang="ko-KR" sz="1100" dirty="0"/>
-                        <a:t>DI/DO/</a:t>
-                      </a:r>
-                    </a:p>
-                    <a:p>
-                      <a:pPr algn="ctr" latinLnBrk="1"/>
-                      <a:r>
-                        <a:rPr lang="en-US" altLang="ko-KR" sz="1100" dirty="0"/>
-                        <a:t>AI/AO</a:t>
+                        <a:t>0.535 kg</a:t>
                       </a:r>
                       <a:endParaRPr lang="ko-KR" altLang="en-US" sz="1100" dirty="0"/>
                     </a:p>
@@ -10022,22 +9772,9 @@
                       </a:pPr>
                       <a:r>
                         <a:rPr lang="en-US" altLang="ko-KR" sz="1100" dirty="0"/>
-                        <a:t>14/10/0/0</a:t>
-                      </a:r>
-                    </a:p>
-                  </a:txBody>
-                  <a:tcPr anchor="ctr"/>
-                </a:tc>
-                <a:tc>
-                  <a:txBody>
-                    <a:bodyPr/>
-                    <a:lstStyle/>
-                    <a:p>
-                      <a:pPr algn="ctr" latinLnBrk="1"/>
-                      <a:r>
-                        <a:rPr lang="en-US" altLang="ko-KR" sz="1100" dirty="0"/>
-                        <a:t>14/10/0/0</a:t>
-                      </a:r>
+                        <a:t>0.535 kg</a:t>
+                      </a:r>
+                      <a:endParaRPr lang="ko-KR" altLang="en-US" sz="1100" dirty="0"/>
                     </a:p>
                   </a:txBody>
                   <a:tcPr anchor="ctr"/>
@@ -10065,9 +9802,252 @@
                         <a:defRPr/>
                       </a:pPr>
                       <a:r>
+                        <a:rPr lang="en-US" altLang="ko-KR" sz="1100" dirty="0">
+                          <a:solidFill>
+                            <a:srgbClr val="FF0000"/>
+                          </a:solidFill>
+                        </a:rPr>
+                        <a:t>1.705 kg</a:t>
+                      </a:r>
+                    </a:p>
+                  </a:txBody>
+                  <a:tcPr anchor="ctr"/>
+                </a:tc>
+                <a:extLst>
+                  <a:ext uri="{0D108BD9-81ED-4DB2-BD59-A6C34878D82A}">
+                    <a16:rowId xmlns:a16="http://schemas.microsoft.com/office/drawing/2014/main" val="1215849545"/>
+                  </a:ext>
+                </a:extLst>
+              </a:tr>
+              <a:tr h="405350">
+                <a:tc>
+                  <a:txBody>
+                    <a:bodyPr/>
+                    <a:lstStyle/>
+                    <a:p>
+                      <a:pPr algn="ctr" latinLnBrk="1"/>
+                      <a:r>
+                        <a:rPr lang="ko-KR" altLang="en-US" sz="1100" dirty="0"/>
+                        <a:t>메모리</a:t>
+                      </a:r>
+                    </a:p>
+                  </a:txBody>
+                  <a:tcPr anchor="ctr"/>
+                </a:tc>
+                <a:tc>
+                  <a:txBody>
+                    <a:bodyPr/>
+                    <a:lstStyle/>
+                    <a:p>
+                      <a:pPr algn="ctr" latinLnBrk="1"/>
+                      <a:r>
+                        <a:rPr lang="ko-KR" altLang="ko-KR" sz="1100" dirty="0"/>
+                        <a:t>64 MB RAM</a:t>
+                      </a:r>
+                      <a:endParaRPr lang="en-US" altLang="ko-KR" sz="1100" dirty="0"/>
+                    </a:p>
+                    <a:p>
+                      <a:pPr algn="ctr" latinLnBrk="1"/>
+                      <a:r>
+                        <a:rPr lang="ko-KR" altLang="ko-KR" sz="1100" dirty="0"/>
+                        <a:t>128 MB </a:t>
+                      </a:r>
+                      <a:r>
+                        <a:rPr lang="ko-KR" altLang="ko-KR" sz="1100" dirty="0" err="1"/>
+                        <a:t>Flash</a:t>
+                      </a:r>
+                      <a:endParaRPr lang="en-US" altLang="ko-KR" sz="1100" dirty="0"/>
+                    </a:p>
+                  </a:txBody>
+                  <a:tcPr anchor="ctr"/>
+                </a:tc>
+                <a:tc>
+                  <a:txBody>
+                    <a:bodyPr/>
+                    <a:lstStyle/>
+                    <a:p>
+                      <a:pPr algn="ctr" latinLnBrk="1"/>
+                      <a:r>
+                        <a:rPr lang="ko-KR" altLang="ko-KR" sz="1100" dirty="0"/>
+                        <a:t>64 MB RAM</a:t>
+                      </a:r>
+                      <a:endParaRPr lang="en-US" altLang="ko-KR" sz="1100" dirty="0"/>
+                    </a:p>
+                    <a:p>
+                      <a:pPr algn="ctr" latinLnBrk="1"/>
+                      <a:r>
+                        <a:rPr lang="ko-KR" altLang="ko-KR" sz="1100" dirty="0"/>
+                        <a:t>128 MB </a:t>
+                      </a:r>
+                      <a:r>
+                        <a:rPr lang="ko-KR" altLang="ko-KR" sz="1100" dirty="0" err="1"/>
+                        <a:t>Flash</a:t>
+                      </a:r>
+                      <a:endParaRPr lang="en-US" altLang="ko-KR" sz="1100" dirty="0"/>
+                    </a:p>
+                  </a:txBody>
+                  <a:tcPr anchor="ctr"/>
+                </a:tc>
+                <a:tc>
+                  <a:txBody>
+                    <a:bodyPr/>
+                    <a:lstStyle/>
+                    <a:p>
+                      <a:pPr algn="ctr" latinLnBrk="1"/>
+                      <a:r>
+                        <a:rPr lang="ko-KR" altLang="ko-KR" sz="1100" dirty="0"/>
+                        <a:t>64 MB RAM</a:t>
+                      </a:r>
+                      <a:endParaRPr lang="en-US" altLang="ko-KR" sz="1100" dirty="0"/>
+                    </a:p>
+                    <a:p>
+                      <a:pPr algn="ctr" latinLnBrk="1"/>
+                      <a:r>
+                        <a:rPr lang="ko-KR" altLang="ko-KR" sz="1100" dirty="0"/>
+                        <a:t>128 MB </a:t>
+                      </a:r>
+                      <a:r>
+                        <a:rPr lang="ko-KR" altLang="ko-KR" sz="1100" dirty="0" err="1"/>
+                        <a:t>Flash</a:t>
+                      </a:r>
+                      <a:endParaRPr lang="en-US" altLang="ko-KR" sz="1100" dirty="0"/>
+                    </a:p>
+                  </a:txBody>
+                  <a:tcPr anchor="ctr"/>
+                </a:tc>
+                <a:tc>
+                  <a:txBody>
+                    <a:bodyPr/>
+                    <a:lstStyle/>
+                    <a:p>
+                      <a:pPr algn="ctr" latinLnBrk="1"/>
+                      <a:r>
+                        <a:rPr lang="ko-KR" altLang="ko-KR" sz="1100" dirty="0"/>
+                        <a:t>64 MB RAM</a:t>
+                      </a:r>
+                      <a:endParaRPr lang="en-US" altLang="ko-KR" sz="1100" dirty="0"/>
+                    </a:p>
+                    <a:p>
+                      <a:pPr algn="ctr" latinLnBrk="1"/>
+                      <a:r>
+                        <a:rPr lang="ko-KR" altLang="ko-KR" sz="1100" dirty="0"/>
+                        <a:t>128 MB </a:t>
+                      </a:r>
+                      <a:r>
+                        <a:rPr lang="ko-KR" altLang="ko-KR" sz="1100" dirty="0" err="1"/>
+                        <a:t>Flash</a:t>
+                      </a:r>
+                      <a:endParaRPr lang="en-US" altLang="ko-KR" sz="1100" dirty="0"/>
+                    </a:p>
+                  </a:txBody>
+                  <a:tcPr anchor="ctr"/>
+                </a:tc>
+                <a:tc>
+                  <a:txBody>
+                    <a:bodyPr/>
+                    <a:lstStyle/>
+                    <a:p>
+                      <a:pPr algn="ctr" latinLnBrk="1"/>
+                      <a:r>
+                        <a:rPr lang="ko-KR" altLang="ko-KR" sz="1100" dirty="0"/>
+                        <a:t>64 MB RAM</a:t>
+                      </a:r>
+                      <a:endParaRPr lang="en-US" altLang="ko-KR" sz="1100" dirty="0"/>
+                    </a:p>
+                    <a:p>
+                      <a:pPr algn="ctr" latinLnBrk="1"/>
+                      <a:r>
+                        <a:rPr lang="ko-KR" altLang="ko-KR" sz="1100" dirty="0"/>
+                        <a:t>128 MB </a:t>
+                      </a:r>
+                      <a:r>
+                        <a:rPr lang="ko-KR" altLang="ko-KR" sz="1100" dirty="0" err="1"/>
+                        <a:t>Flash</a:t>
+                      </a:r>
+                      <a:endParaRPr lang="en-US" altLang="ko-KR" sz="1100" dirty="0"/>
+                    </a:p>
+                  </a:txBody>
+                  <a:tcPr anchor="ctr"/>
+                </a:tc>
+                <a:tc>
+                  <a:txBody>
+                    <a:bodyPr/>
+                    <a:lstStyle/>
+                    <a:p>
+                      <a:pPr algn="ctr" latinLnBrk="1"/>
+                      <a:r>
+                        <a:rPr lang="ko-KR" altLang="ko-KR" sz="1100" dirty="0"/>
+                        <a:t>64 MB RAM</a:t>
+                      </a:r>
+                      <a:endParaRPr lang="en-US" altLang="ko-KR" sz="1100" dirty="0"/>
+                    </a:p>
+                    <a:p>
+                      <a:pPr algn="ctr" latinLnBrk="1"/>
+                      <a:r>
+                        <a:rPr lang="ko-KR" altLang="ko-KR" sz="1100" dirty="0"/>
+                        <a:t>128 MB </a:t>
+                      </a:r>
+                      <a:r>
+                        <a:rPr lang="ko-KR" altLang="ko-KR" sz="1100" dirty="0" err="1"/>
+                        <a:t>Flash</a:t>
+                      </a:r>
+                      <a:endParaRPr lang="en-US" altLang="ko-KR" sz="1100" dirty="0"/>
+                    </a:p>
+                  </a:txBody>
+                  <a:tcPr anchor="ctr"/>
+                </a:tc>
+                <a:tc>
+                  <a:txBody>
+                    <a:bodyPr/>
+                    <a:lstStyle/>
+                    <a:p>
+                      <a:pPr algn="ctr" latinLnBrk="1"/>
+                      <a:r>
+                        <a:rPr lang="ko-KR" altLang="ko-KR" sz="1100" dirty="0"/>
+                        <a:t>64 MB RAM</a:t>
+                      </a:r>
+                      <a:endParaRPr lang="en-US" altLang="ko-KR" sz="1100" dirty="0"/>
+                    </a:p>
+                    <a:p>
+                      <a:pPr algn="ctr" latinLnBrk="1"/>
+                      <a:r>
+                        <a:rPr lang="ko-KR" altLang="ko-KR" sz="1100" dirty="0"/>
+                        <a:t>128 MB </a:t>
+                      </a:r>
+                      <a:r>
+                        <a:rPr lang="ko-KR" altLang="ko-KR" sz="1100" dirty="0" err="1"/>
+                        <a:t>Flash</a:t>
+                      </a:r>
+                      <a:endParaRPr lang="en-US" altLang="ko-KR" sz="1100" dirty="0"/>
+                    </a:p>
+                  </a:txBody>
+                  <a:tcPr anchor="ctr"/>
+                </a:tc>
+                <a:extLst>
+                  <a:ext uri="{0D108BD9-81ED-4DB2-BD59-A6C34878D82A}">
+                    <a16:rowId xmlns:a16="http://schemas.microsoft.com/office/drawing/2014/main" val="2379048894"/>
+                  </a:ext>
+                </a:extLst>
+              </a:tr>
+              <a:tr h="405350">
+                <a:tc>
+                  <a:txBody>
+                    <a:bodyPr/>
+                    <a:lstStyle/>
+                    <a:p>
+                      <a:pPr algn="ctr" latinLnBrk="1"/>
+                      <a:r>
                         <a:rPr lang="en-US" altLang="ko-KR" sz="1100" dirty="0"/>
-                        <a:t>24/16/0/0</a:t>
-                      </a:r>
+                        <a:t>DI/DO/</a:t>
+                      </a:r>
+                    </a:p>
+                    <a:p>
+                      <a:pPr algn="ctr" latinLnBrk="1"/>
+                      <a:r>
+                        <a:rPr lang="en-US" altLang="ko-KR" sz="1100" dirty="0"/>
+                        <a:t>AI/AO</a:t>
+                      </a:r>
+                      <a:endParaRPr lang="ko-KR" altLang="en-US" sz="1100" dirty="0"/>
                     </a:p>
                   </a:txBody>
                   <a:tcPr anchor="ctr"/>
@@ -10096,7 +10076,21 @@
                       </a:pPr>
                       <a:r>
                         <a:rPr lang="en-US" altLang="ko-KR" sz="1100" dirty="0"/>
-                        <a:t>24/16/0/0</a:t>
+                        <a:t>14/10/0/0</a:t>
+                      </a:r>
+                    </a:p>
+                  </a:txBody>
+                  <a:tcPr anchor="ctr"/>
+                </a:tc>
+                <a:tc>
+                  <a:txBody>
+                    <a:bodyPr/>
+                    <a:lstStyle/>
+                    <a:p>
+                      <a:pPr algn="ctr" latinLnBrk="1"/>
+                      <a:r>
+                        <a:rPr lang="en-US" altLang="ko-KR" sz="1100" dirty="0"/>
+                        <a:t>14/10/0/0</a:t>
                       </a:r>
                     </a:p>
                   </a:txBody>
@@ -10126,7 +10120,7 @@
                       </a:pPr>
                       <a:r>
                         <a:rPr lang="en-US" altLang="ko-KR" sz="1100" dirty="0"/>
-                        <a:t>14/10/0/2</a:t>
+                        <a:t>24/16/0/0</a:t>
                       </a:r>
                     </a:p>
                   </a:txBody>
@@ -10156,7 +10150,7 @@
                       </a:pPr>
                       <a:r>
                         <a:rPr lang="en-US" altLang="ko-KR" sz="1100" dirty="0"/>
-                        <a:t>14/10/0/2</a:t>
+                        <a:t>24/16/0/0</a:t>
                       </a:r>
                     </a:p>
                   </a:txBody>
@@ -10185,33 +10179,8 @@
                         <a:defRPr/>
                       </a:pPr>
                       <a:r>
-                        <a:rPr lang="en-US" altLang="ko-KR" sz="1100" dirty="0">
-                          <a:solidFill>
-                            <a:srgbClr val="FF0000"/>
-                          </a:solidFill>
-                        </a:rPr>
-                        <a:t>104/56/0/4</a:t>
-                      </a:r>
-                    </a:p>
-                  </a:txBody>
-                  <a:tcPr anchor="ctr"/>
-                </a:tc>
-                <a:extLst>
-                  <a:ext uri="{0D108BD9-81ED-4DB2-BD59-A6C34878D82A}">
-                    <a16:rowId xmlns:a16="http://schemas.microsoft.com/office/drawing/2014/main" val="1442704647"/>
-                  </a:ext>
-                </a:extLst>
-              </a:tr>
-              <a:tr h="411585">
-                <a:tc>
-                  <a:txBody>
-                    <a:bodyPr/>
-                    <a:lstStyle/>
-                    <a:p>
-                      <a:pPr algn="ctr" latinLnBrk="1"/>
-                      <a:r>
-                        <a:rPr lang="ko-KR" altLang="en-US" sz="1100" dirty="0"/>
-                        <a:t>선급인증</a:t>
+                        <a:rPr lang="en-US" altLang="ko-KR" sz="1100" dirty="0"/>
+                        <a:t>14/10/0/2</a:t>
                       </a:r>
                     </a:p>
                   </a:txBody>
@@ -10240,8 +10209,8 @@
                         <a:defRPr/>
                       </a:pPr>
                       <a:r>
-                        <a:rPr lang="en-US" altLang="ko-KR" sz="1000" dirty="0"/>
-                        <a:t>LR, ABS, DNV-GL, KR</a:t>
+                        <a:rPr lang="en-US" altLang="ko-KR" sz="1100" dirty="0"/>
+                        <a:t>14/10/0/2</a:t>
                       </a:r>
                     </a:p>
                   </a:txBody>
@@ -10270,8 +10239,33 @@
                         <a:defRPr/>
                       </a:pPr>
                       <a:r>
-                        <a:rPr lang="en-US" altLang="ko-KR" sz="1000" dirty="0"/>
-                        <a:t>LR, ABS, DNV-GL, KR</a:t>
+                        <a:rPr lang="en-US" altLang="ko-KR" sz="1100" dirty="0">
+                          <a:solidFill>
+                            <a:srgbClr val="FF0000"/>
+                          </a:solidFill>
+                        </a:rPr>
+                        <a:t>104/56/0/4</a:t>
+                      </a:r>
+                    </a:p>
+                  </a:txBody>
+                  <a:tcPr anchor="ctr"/>
+                </a:tc>
+                <a:extLst>
+                  <a:ext uri="{0D108BD9-81ED-4DB2-BD59-A6C34878D82A}">
+                    <a16:rowId xmlns:a16="http://schemas.microsoft.com/office/drawing/2014/main" val="1442704647"/>
+                  </a:ext>
+                </a:extLst>
+              </a:tr>
+              <a:tr h="411585">
+                <a:tc>
+                  <a:txBody>
+                    <a:bodyPr/>
+                    <a:lstStyle/>
+                    <a:p>
+                      <a:pPr algn="ctr" latinLnBrk="1"/>
+                      <a:r>
+                        <a:rPr lang="ko-KR" altLang="en-US" sz="1100" dirty="0"/>
+                        <a:t>선급인증</a:t>
                       </a:r>
                     </a:p>
                   </a:txBody>
@@ -10427,6 +10421,66 @@
                   </a:txBody>
                   <a:tcPr anchor="ctr"/>
                 </a:tc>
+                <a:tc>
+                  <a:txBody>
+                    <a:bodyPr/>
+                    <a:lstStyle/>
+                    <a:p>
+                      <a:pPr marL="0" marR="0" lvl="0" indent="0" algn="ctr" defTabSz="914400" rtl="0" eaLnBrk="1" fontAlgn="auto" latinLnBrk="1" hangingPunct="1">
+                        <a:lnSpc>
+                          <a:spcPct val="100000"/>
+                        </a:lnSpc>
+                        <a:spcBef>
+                          <a:spcPts val="0"/>
+                        </a:spcBef>
+                        <a:spcAft>
+                          <a:spcPts val="0"/>
+                        </a:spcAft>
+                        <a:buClrTx/>
+                        <a:buSzTx/>
+                        <a:buFontTx/>
+                        <a:buNone/>
+                        <a:tabLst/>
+                        <a:defRPr/>
+                      </a:pPr>
+                      <a:r>
+                        <a:rPr lang="en-US" altLang="ko-KR" sz="1000" dirty="0"/>
+                        <a:t>LR, ABS, DNV-GL, KR</a:t>
+                      </a:r>
+                    </a:p>
+                  </a:txBody>
+                  <a:tcPr anchor="ctr"/>
+                </a:tc>
+                <a:tc>
+                  <a:txBody>
+                    <a:bodyPr/>
+                    <a:lstStyle/>
+                    <a:p>
+                      <a:pPr marL="0" marR="0" lvl="0" indent="0" algn="ctr" defTabSz="914400" rtl="0" eaLnBrk="1" fontAlgn="auto" latinLnBrk="1" hangingPunct="1">
+                        <a:lnSpc>
+                          <a:spcPct val="100000"/>
+                        </a:lnSpc>
+                        <a:spcBef>
+                          <a:spcPts val="0"/>
+                        </a:spcBef>
+                        <a:spcAft>
+                          <a:spcPts val="0"/>
+                        </a:spcAft>
+                        <a:buClrTx/>
+                        <a:buSzTx/>
+                        <a:buFontTx/>
+                        <a:buNone/>
+                        <a:tabLst/>
+                        <a:defRPr/>
+                      </a:pPr>
+                      <a:r>
+                        <a:rPr lang="en-US" altLang="ko-KR" sz="1000" dirty="0"/>
+                        <a:t>LR, ABS, DNV-GL, KR</a:t>
+                      </a:r>
+                    </a:p>
+                  </a:txBody>
+                  <a:tcPr anchor="ctr"/>
+                </a:tc>
                 <a:extLst>
                   <a:ext uri="{0D108BD9-81ED-4DB2-BD59-A6C34878D82A}">
                     <a16:rowId xmlns:a16="http://schemas.microsoft.com/office/drawing/2014/main" val="915298277"/>
@@ -10455,7 +10509,14 @@
                     <a:lstStyle/>
                     <a:p>
                       <a:pPr algn="ctr" latinLnBrk="1"/>
-                      <a:endParaRPr lang="en-US" altLang="ko-KR" sz="1100" dirty="0"/>
+                      <a:r>
+                        <a:rPr sz="1000">
+                          <a:solidFill>
+                            <a:srgbClr val="FF0000"/>
+                          </a:solidFill>
+                        </a:rPr>
+                        <a:t>Marine Energy Saving System, Marine Crane, Marine Scrubber</a:t>
+                      </a:r>
                     </a:p>
                   </a:txBody>
                   <a:tcPr anchor="ctr"/>

</xml_diff>

<commit_message>
Unify red markings and font sizes in revised decks
Co-Authored-By: Claude Opus 5.5 <noreply@anthropic.com>
Claude-Session: https://claude.ai/code/session_01GjFrCobQqqs1TtLcuKd8BA
</commit_message>
<xml_diff>
--- a/최종_제출본/PLC_사양서_261006_수정.pptx
+++ b/최종_제출본/PLC_사양서_261006_수정.pptx
@@ -9131,14 +9131,14 @@
                     <a:p>
                       <a:pPr algn="ctr" latinLnBrk="1"/>
                       <a:r>
-                        <a:rPr lang="en-US" altLang="ko-KR" sz="850" dirty="0"/>
+                        <a:rPr lang="en-US" altLang="ko-KR" sz="1000" dirty="0"/>
                         <a:t>TM241CE40T</a:t>
                       </a:r>
                     </a:p>
                     <a:p>
                       <a:pPr algn="ctr" latinLnBrk="1"/>
                       <a:r>
-                        <a:rPr lang="en-US" altLang="ko-KR" sz="850" dirty="0">
+                        <a:rPr lang="en-US" altLang="ko-KR" sz="1000" dirty="0">
                           <a:solidFill>
                             <a:srgbClr val="FF0000"/>
                           </a:solidFill>
@@ -9149,7 +9149,7 @@
                     <a:p>
                       <a:pPr algn="ctr" latinLnBrk="1"/>
                       <a:r>
-                        <a:rPr lang="en-US" altLang="ko-KR" sz="850" dirty="0">
+                        <a:rPr lang="en-US" altLang="ko-KR" sz="1000" dirty="0">
                           <a:solidFill>
                             <a:srgbClr val="FF0000"/>
                           </a:solidFill>
@@ -9160,14 +9160,14 @@
                     <a:p>
                       <a:pPr algn="ctr" latinLnBrk="1"/>
                       <a:r>
-                        <a:rPr lang="en-US" altLang="ko-KR" sz="850" dirty="0"/>
+                        <a:rPr lang="en-US" altLang="ko-KR" sz="1000" dirty="0"/>
                         <a:t>TM3DQ8T</a:t>
                       </a:r>
                     </a:p>
                     <a:p>
                       <a:pPr algn="ctr" latinLnBrk="1"/>
                       <a:r>
-                        <a:rPr lang="en-US" altLang="ko-KR" sz="850" dirty="0">
+                        <a:rPr lang="en-US" altLang="ko-KR" sz="1000" dirty="0">
                           <a:solidFill>
                             <a:srgbClr val="FF0000"/>
                           </a:solidFill>
@@ -9178,12 +9178,12 @@
                     <a:p>
                       <a:pPr algn="ctr" latinLnBrk="1"/>
                       <a:r>
-                        <a:rPr lang="en-US" altLang="ko-KR" sz="850" dirty="0">
+                        <a:rPr lang="en-US" altLang="ko-KR" sz="1000" dirty="0">
                           <a:solidFill>
                             <a:srgbClr val="FF0000"/>
                           </a:solidFill>
                         </a:rPr>
-                        <a:t>TM3XTRA1/XREC1</a:t>
+                        <a:t>TM3XTRA1/REC1</a:t>
                       </a:r>
                     </a:p>
                   </a:txBody>
@@ -9479,12 +9479,12 @@
                         <a:defRPr/>
                       </a:pPr>
                       <a:r>
-                        <a:rPr lang="pl-PL" altLang="ko-KR" sz="700" dirty="0">
+                        <a:rPr lang="pl-PL" altLang="ko-KR" sz="800" dirty="0">
                           <a:solidFill>
                             <a:srgbClr val="FF0000"/>
                           </a:solidFill>
                         </a:rPr>
-                        <a:t>190 × 95 × 90</a:t>
+                        <a:t>190×95×90</a:t>
                       </a:r>
                     </a:p>
                     <a:p>
@@ -9506,12 +9506,12 @@
                         <a:defRPr/>
                       </a:pPr>
                       <a:r>
-                        <a:rPr lang="pl-PL" altLang="ko-KR" sz="700" dirty="0">
+                        <a:rPr lang="pl-PL" altLang="ko-KR" sz="800" dirty="0">
                           <a:solidFill>
                             <a:srgbClr val="FF0000"/>
                           </a:solidFill>
                         </a:rPr>
-                        <a:t>27.4 × 84.6 × 90 ×8</a:t>
+                        <a:t>27.4×84.6×90 (×8)</a:t>
                       </a:r>
                     </a:p>
                     <a:p>
@@ -9533,12 +9533,12 @@
                         <a:defRPr/>
                       </a:pPr>
                       <a:r>
-                        <a:rPr lang="pl-PL" altLang="ko-KR" sz="700" dirty="0">
+                        <a:rPr lang="pl-PL" altLang="ko-KR" sz="800" dirty="0">
                           <a:solidFill>
                             <a:srgbClr val="FF0000"/>
                           </a:solidFill>
                         </a:rPr>
-                        <a:t>23.6 × 70 × 90</a:t>
+                        <a:t>23.6×70×90</a:t>
                       </a:r>
                     </a:p>
                     <a:p>
@@ -9560,12 +9560,12 @@
                         <a:defRPr/>
                       </a:pPr>
                       <a:r>
-                        <a:rPr lang="pl-PL" altLang="ko-KR" sz="700" dirty="0">
+                        <a:rPr lang="pl-PL" altLang="ko-KR" sz="800" dirty="0">
                           <a:solidFill>
                             <a:srgbClr val="FF0000"/>
                           </a:solidFill>
                         </a:rPr>
-                        <a:t>23.65 × 73.3 × 90 ×2</a:t>
+                        <a:t>23.65×73.3×90 (×2)</a:t>
                       </a:r>
                     </a:p>
                   </a:txBody>
@@ -9802,7 +9802,7 @@
                         <a:defRPr/>
                       </a:pPr>
                       <a:r>
-                        <a:rPr lang="en-US" altLang="ko-KR" sz="1100" dirty="0">
+                        <a:rPr lang="en-US" altLang="ko-KR" sz="1100" dirty="0" b="1">
                           <a:solidFill>
                             <a:srgbClr val="FF0000"/>
                           </a:solidFill>
@@ -10239,7 +10239,7 @@
                         <a:defRPr/>
                       </a:pPr>
                       <a:r>
-                        <a:rPr lang="en-US" altLang="ko-KR" sz="1100" dirty="0">
+                        <a:rPr lang="en-US" altLang="ko-KR" sz="1100" dirty="0" b="1">
                           <a:solidFill>
                             <a:srgbClr val="FF0000"/>
                           </a:solidFill>
@@ -10510,7 +10510,7 @@
                     <a:p>
                       <a:pPr algn="ctr" latinLnBrk="1"/>
                       <a:r>
-                        <a:rPr sz="1000">
+                        <a:rPr sz="1100">
                           <a:solidFill>
                             <a:srgbClr val="FF0000"/>
                           </a:solidFill>
@@ -10697,7 +10697,7 @@
                     <a:p>
                       <a:pPr algn="ctr" latinLnBrk="1"/>
                       <a:r>
-                        <a:rPr lang="ko-KR" altLang="en-US" sz="800" dirty="0" b="1">
+                        <a:rPr lang="ko-KR" altLang="en-US" sz="1100" dirty="0" b="1">
                           <a:solidFill>
                             <a:srgbClr val="FF0000"/>
                           </a:solidFill>
@@ -10705,28 +10705,17 @@
                         <a:t>제안 가격</a:t>
                       </a:r>
                     </a:p>
+                  </a:txBody>
+                  <a:tcPr anchor="ctr"/>
+                </a:tc>
+                <a:tc>
+                  <a:txBody>
+                    <a:bodyPr/>
+                    <a:lstStyle/>
                     <a:p>
                       <a:pPr algn="ctr" latinLnBrk="1"/>
                       <a:r>
-                        <a:rPr lang="ko-KR" altLang="en-US" sz="800" dirty="0" b="1">
-                          <a:solidFill>
-                            <a:srgbClr val="FF0000"/>
-                          </a:solidFill>
-                        </a:rPr>
-                        <a:t>(VAT별도)</a:t>
-                      </a:r>
-                    </a:p>
-                  </a:txBody>
-                  <a:tcPr anchor="ctr"/>
-                </a:tc>
-                <a:tc>
-                  <a:txBody>
-                    <a:bodyPr/>
-                    <a:lstStyle/>
-                    <a:p>
-                      <a:pPr algn="ctr" latinLnBrk="1"/>
-                      <a:r>
-                        <a:rPr b="1" sz="1000">
+                        <a:rPr b="1" sz="1100">
                           <a:solidFill>
                             <a:srgbClr val="FF0000"/>
                           </a:solidFill>
@@ -10744,7 +10733,7 @@
                     <a:p>
                       <a:pPr algn="ctr" latinLnBrk="1"/>
                       <a:r>
-                        <a:rPr b="1" sz="1000">
+                        <a:rPr b="1" sz="1100">
                           <a:solidFill>
                             <a:srgbClr val="FF0000"/>
                           </a:solidFill>
@@ -10762,7 +10751,7 @@
                     <a:p>
                       <a:pPr algn="ctr" latinLnBrk="1"/>
                       <a:r>
-                        <a:rPr b="1" sz="1000">
+                        <a:rPr b="1" sz="1100">
                           <a:solidFill>
                             <a:srgbClr val="FF0000"/>
                           </a:solidFill>
@@ -10780,7 +10769,7 @@
                     <a:p>
                       <a:pPr algn="ctr" latinLnBrk="1"/>
                       <a:r>
-                        <a:rPr b="1" sz="1000">
+                        <a:rPr b="1" sz="1100">
                           <a:solidFill>
                             <a:srgbClr val="FF0000"/>
                           </a:solidFill>
@@ -10798,7 +10787,7 @@
                     <a:p>
                       <a:pPr algn="ctr" latinLnBrk="1"/>
                       <a:r>
-                        <a:rPr b="1" sz="1000">
+                        <a:rPr b="1" sz="1100">
                           <a:solidFill>
                             <a:srgbClr val="FF0000"/>
                           </a:solidFill>
@@ -10816,7 +10805,7 @@
                     <a:p>
                       <a:pPr algn="ctr" latinLnBrk="1"/>
                       <a:r>
-                        <a:rPr b="1" sz="1000">
+                        <a:rPr b="1" sz="1100">
                           <a:solidFill>
                             <a:srgbClr val="FF0000"/>
                           </a:solidFill>
@@ -10834,7 +10823,7 @@
                     <a:p>
                       <a:pPr algn="ctr" latinLnBrk="1"/>
                       <a:r>
-                        <a:rPr b="1" sz="1000">
+                        <a:rPr b="1" sz="1100">
                           <a:solidFill>
                             <a:srgbClr val="FF0000"/>
                           </a:solidFill>
@@ -11021,6 +11010,17 @@
               <a:t>세부 내용 표</a:t>
             </a:r>
             <a:endParaRPr lang="en-US" altLang="ko-KR" sz="1250" dirty="0"/>
+            <a:r>
+              <a:rPr lang="en-US" altLang="ko-KR" sz="1250" dirty="0" b="1">
+                <a:solidFill>
+                  <a:srgbClr val="FF0000"/>
+                </a:solidFill>
+                <a:latin typeface="Malgun Gothic" pitchFamily="34" charset="0"/>
+                <a:ea typeface="Malgun Gothic" pitchFamily="34" charset="-122"/>
+                <a:cs typeface="Malgun Gothic" pitchFamily="34" charset="-120"/>
+              </a:rPr>
+              <a:t>   (제안 가격: 1대 기준, VAT 별도, 2027년 가격)</a:t>
+            </a:r>
           </a:p>
         </p:txBody>
       </p:sp>

</xml_diff>